<commit_message>
Upgrade model usage and Inbox sample workflows
</commit_message>
<xml_diff>
--- a/Output/research-slides/public-sample/temperature-scan-example.pptx
+++ b/Output/research-slides/public-sample/temperature-scan-example.pptx
@@ -2,13 +2,17 @@
 <file path=ppt/presentation.xml><?xml version="1.0" encoding="utf-8"?>
 <p:presentation xmlns:p="http://schemas.openxmlformats.org/presentationml/2006/main">
   <p:sldMasterIdLst>
-    <p:sldMasterId xmlns:r="http://schemas.openxmlformats.org/officeDocument/2006/relationships" id="2147483648" r:id="R1841732c0c0a4305"/>
+    <p:sldMasterId xmlns:r="http://schemas.openxmlformats.org/officeDocument/2006/relationships" id="2147483648" r:id="R344ecc9aef6a4ce5"/>
   </p:sldMasterIdLst>
   <p:notesMasterIdLst>
-    <p:notesMasterId xmlns:r="http://schemas.openxmlformats.org/officeDocument/2006/relationships" r:id="R139b9a4855d24d34"/>
+    <p:notesMasterId xmlns:r="http://schemas.openxmlformats.org/officeDocument/2006/relationships" r:id="R52db68a931a74268"/>
   </p:notesMasterIdLst>
   <p:sldIdLst>
-    <p:sldId xmlns:r="http://schemas.openxmlformats.org/officeDocument/2006/relationships" id="256" r:id="R8b022824a19f4965"/>
+    <p:sldId xmlns:r="http://schemas.openxmlformats.org/officeDocument/2006/relationships" id="256" r:id="R362963d2b438403f"/>
+    <p:sldId xmlns:r="http://schemas.openxmlformats.org/officeDocument/2006/relationships" id="257" r:id="Rcb7fe724793d4a60"/>
+    <p:sldId xmlns:r="http://schemas.openxmlformats.org/officeDocument/2006/relationships" id="258" r:id="R65098c6969d14698"/>
+    <p:sldId xmlns:r="http://schemas.openxmlformats.org/officeDocument/2006/relationships" id="259" r:id="Rd879e20632444a4f"/>
+    <p:sldId xmlns:r="http://schemas.openxmlformats.org/officeDocument/2006/relationships" id="260" r:id="Rf07968381e114dcb"/>
   </p:sldIdLst>
   <p:sldSz cx="12192000" cy="6858000"/>
   <p:notesSz cx="6858000" cy="9144000"/>
@@ -442,7 +446,287 @@
           <a:lstStyle xmlns:a="http://schemas.openxmlformats.org/drawingml/2006/main"/>
           <a:p xmlns:a="http://schemas.openxmlformats.org/drawingml/2006/main">
             <a:r>
-              <a:t>All values are synthetic and are included only to demonstrate the completed-project preview.</a:t>
+              <a:t>All values are synthetic and intended only for testing Research Starter.</a:t>
+            </a:r>
+          </a:p>
+        </p:txBody>
+      </p:sp>
+      <p:sp>
+        <p:nvSpPr>
+          <p:cNvPr id="4" name="Slide Number Placeholder 3"/>
+          <p:cNvSpPr>
+            <a:spLocks xmlns:a="http://schemas.openxmlformats.org/drawingml/2006/main" noGrp="1"/>
+          </p:cNvSpPr>
+          <p:nvPr>
+            <p:ph type="sldNum" idx="5"/>
+          </p:nvPr>
+        </p:nvSpPr>
+        <p:spPr/>
+        <p:txBody>
+          <a:bodyPr xmlns:a="http://schemas.openxmlformats.org/drawingml/2006/main"/>
+          <a:lstStyle xmlns:a="http://schemas.openxmlformats.org/drawingml/2006/main"/>
+          <a:p xmlns:a="http://schemas.openxmlformats.org/drawingml/2006/main"/>
+        </p:txBody>
+      </p:sp>
+    </p:spTree>
+  </p:cSld>
+  <p:clrMapOvr>
+    <a:masterClrMapping xmlns:a="http://schemas.openxmlformats.org/drawingml/2006/main"/>
+  </p:clrMapOvr>
+</p:notes>
+</file>
+
+<file path=ppt/notesSlides/notesSlide2.xml><?xml version="1.0" encoding="utf-8"?>
+<p:notes xmlns:p="http://schemas.openxmlformats.org/presentationml/2006/main">
+  <p:cSld>
+    <p:spTree>
+      <p:nvGrpSpPr>
+        <p:cNvPr id="1" name=""/>
+        <p:cNvGrpSpPr/>
+        <p:nvPr/>
+      </p:nvGrpSpPr>
+      <p:grpSpPr>
+        <a:xfrm xmlns:a="http://schemas.openxmlformats.org/drawingml/2006/main"/>
+      </p:grpSpPr>
+      <p:sp>
+        <p:nvSpPr>
+          <p:cNvPr id="2" name="Slide Image Placeholder 1"/>
+          <p:cNvSpPr>
+            <a:spLocks xmlns:a="http://schemas.openxmlformats.org/drawingml/2006/main" noGrp="1"/>
+          </p:cNvSpPr>
+          <p:nvPr>
+            <p:ph type="sldImg" idx="0"/>
+          </p:nvPr>
+        </p:nvSpPr>
+        <p:spPr/>
+      </p:sp>
+      <p:sp>
+        <p:nvSpPr>
+          <p:cNvPr id="3" name="Notes Placeholder 2"/>
+          <p:cNvSpPr>
+            <a:spLocks xmlns:a="http://schemas.openxmlformats.org/drawingml/2006/main" noGrp="1"/>
+          </p:cNvSpPr>
+          <p:nvPr>
+            <p:ph type="body" idx="1"/>
+          </p:nvPr>
+        </p:nvSpPr>
+        <p:spPr/>
+        <p:txBody>
+          <a:bodyPr xmlns:a="http://schemas.openxmlformats.org/drawingml/2006/main"/>
+          <a:lstStyle xmlns:a="http://schemas.openxmlformats.org/drawingml/2006/main"/>
+          <a:p xmlns:a="http://schemas.openxmlformats.org/drawingml/2006/main">
+            <a:r>
+              <a:t>The normalization and uncertainty values are synthetic.</a:t>
+            </a:r>
+          </a:p>
+        </p:txBody>
+      </p:sp>
+      <p:sp>
+        <p:nvSpPr>
+          <p:cNvPr id="4" name="Slide Number Placeholder 3"/>
+          <p:cNvSpPr>
+            <a:spLocks xmlns:a="http://schemas.openxmlformats.org/drawingml/2006/main" noGrp="1"/>
+          </p:cNvSpPr>
+          <p:nvPr>
+            <p:ph type="sldNum" idx="5"/>
+          </p:nvPr>
+        </p:nvSpPr>
+        <p:spPr/>
+        <p:txBody>
+          <a:bodyPr xmlns:a="http://schemas.openxmlformats.org/drawingml/2006/main"/>
+          <a:lstStyle xmlns:a="http://schemas.openxmlformats.org/drawingml/2006/main"/>
+          <a:p xmlns:a="http://schemas.openxmlformats.org/drawingml/2006/main"/>
+        </p:txBody>
+      </p:sp>
+    </p:spTree>
+  </p:cSld>
+  <p:clrMapOvr>
+    <a:masterClrMapping xmlns:a="http://schemas.openxmlformats.org/drawingml/2006/main"/>
+  </p:clrMapOvr>
+</p:notes>
+</file>
+
+<file path=ppt/notesSlides/notesSlide3.xml><?xml version="1.0" encoding="utf-8"?>
+<p:notes xmlns:p="http://schemas.openxmlformats.org/presentationml/2006/main">
+  <p:cSld>
+    <p:spTree>
+      <p:nvGrpSpPr>
+        <p:cNvPr id="1" name=""/>
+        <p:cNvGrpSpPr/>
+        <p:nvPr/>
+      </p:nvGrpSpPr>
+      <p:grpSpPr>
+        <a:xfrm xmlns:a="http://schemas.openxmlformats.org/drawingml/2006/main"/>
+      </p:grpSpPr>
+      <p:sp>
+        <p:nvSpPr>
+          <p:cNvPr id="2" name="Slide Image Placeholder 1"/>
+          <p:cNvSpPr>
+            <a:spLocks xmlns:a="http://schemas.openxmlformats.org/drawingml/2006/main" noGrp="1"/>
+          </p:cNvSpPr>
+          <p:nvPr>
+            <p:ph type="sldImg" idx="0"/>
+          </p:nvPr>
+        </p:nvSpPr>
+        <p:spPr/>
+      </p:sp>
+      <p:sp>
+        <p:nvSpPr>
+          <p:cNvPr id="3" name="Notes Placeholder 2"/>
+          <p:cNvSpPr>
+            <a:spLocks xmlns:a="http://schemas.openxmlformats.org/drawingml/2006/main" noGrp="1"/>
+          </p:cNvSpPr>
+          <p:nvPr>
+            <p:ph type="body" idx="1"/>
+          </p:nvPr>
+        </p:nvSpPr>
+        <p:spPr/>
+        <p:txBody>
+          <a:bodyPr xmlns:a="http://schemas.openxmlformats.org/drawingml/2006/main"/>
+          <a:lstStyle xmlns:a="http://schemas.openxmlformats.org/drawingml/2006/main"/>
+          <a:p xmlns:a="http://schemas.openxmlformats.org/drawingml/2006/main">
+            <a:r>
+              <a:t>Editable chart. Source: bundled temperature_scan.csv. Values are synthetic.</a:t>
+            </a:r>
+          </a:p>
+        </p:txBody>
+      </p:sp>
+      <p:sp>
+        <p:nvSpPr>
+          <p:cNvPr id="4" name="Slide Number Placeholder 3"/>
+          <p:cNvSpPr>
+            <a:spLocks xmlns:a="http://schemas.openxmlformats.org/drawingml/2006/main" noGrp="1"/>
+          </p:cNvSpPr>
+          <p:nvPr>
+            <p:ph type="sldNum" idx="5"/>
+          </p:nvPr>
+        </p:nvSpPr>
+        <p:spPr/>
+        <p:txBody>
+          <a:bodyPr xmlns:a="http://schemas.openxmlformats.org/drawingml/2006/main"/>
+          <a:lstStyle xmlns:a="http://schemas.openxmlformats.org/drawingml/2006/main"/>
+          <a:p xmlns:a="http://schemas.openxmlformats.org/drawingml/2006/main"/>
+        </p:txBody>
+      </p:sp>
+    </p:spTree>
+  </p:cSld>
+  <p:clrMapOvr>
+    <a:masterClrMapping xmlns:a="http://schemas.openxmlformats.org/drawingml/2006/main"/>
+  </p:clrMapOvr>
+</p:notes>
+</file>
+
+<file path=ppt/notesSlides/notesSlide4.xml><?xml version="1.0" encoding="utf-8"?>
+<p:notes xmlns:p="http://schemas.openxmlformats.org/presentationml/2006/main">
+  <p:cSld>
+    <p:spTree>
+      <p:nvGrpSpPr>
+        <p:cNvPr id="1" name=""/>
+        <p:cNvGrpSpPr/>
+        <p:nvPr/>
+      </p:nvGrpSpPr>
+      <p:grpSpPr>
+        <a:xfrm xmlns:a="http://schemas.openxmlformats.org/drawingml/2006/main"/>
+      </p:grpSpPr>
+      <p:sp>
+        <p:nvSpPr>
+          <p:cNvPr id="2" name="Slide Image Placeholder 1"/>
+          <p:cNvSpPr>
+            <a:spLocks xmlns:a="http://schemas.openxmlformats.org/drawingml/2006/main" noGrp="1"/>
+          </p:cNvSpPr>
+          <p:nvPr>
+            <p:ph type="sldImg" idx="0"/>
+          </p:nvPr>
+        </p:nvSpPr>
+        <p:spPr/>
+      </p:sp>
+      <p:sp>
+        <p:nvSpPr>
+          <p:cNvPr id="3" name="Notes Placeholder 2"/>
+          <p:cNvSpPr>
+            <a:spLocks xmlns:a="http://schemas.openxmlformats.org/drawingml/2006/main" noGrp="1"/>
+          </p:cNvSpPr>
+          <p:nvPr>
+            <p:ph type="body" idx="1"/>
+          </p:nvPr>
+        </p:nvSpPr>
+        <p:spPr/>
+        <p:txBody>
+          <a:bodyPr xmlns:a="http://schemas.openxmlformats.org/drawingml/2006/main"/>
+          <a:lstStyle xmlns:a="http://schemas.openxmlformats.org/drawingml/2006/main"/>
+          <a:p xmlns:a="http://schemas.openxmlformats.org/drawingml/2006/main">
+            <a:r>
+              <a:t>Calculated from the synthetic CSV. No real experimental claim is made.</a:t>
+            </a:r>
+          </a:p>
+        </p:txBody>
+      </p:sp>
+      <p:sp>
+        <p:nvSpPr>
+          <p:cNvPr id="4" name="Slide Number Placeholder 3"/>
+          <p:cNvSpPr>
+            <a:spLocks xmlns:a="http://schemas.openxmlformats.org/drawingml/2006/main" noGrp="1"/>
+          </p:cNvSpPr>
+          <p:nvPr>
+            <p:ph type="sldNum" idx="5"/>
+          </p:nvPr>
+        </p:nvSpPr>
+        <p:spPr/>
+        <p:txBody>
+          <a:bodyPr xmlns:a="http://schemas.openxmlformats.org/drawingml/2006/main"/>
+          <a:lstStyle xmlns:a="http://schemas.openxmlformats.org/drawingml/2006/main"/>
+          <a:p xmlns:a="http://schemas.openxmlformats.org/drawingml/2006/main"/>
+        </p:txBody>
+      </p:sp>
+    </p:spTree>
+  </p:cSld>
+  <p:clrMapOvr>
+    <a:masterClrMapping xmlns:a="http://schemas.openxmlformats.org/drawingml/2006/main"/>
+  </p:clrMapOvr>
+</p:notes>
+</file>
+
+<file path=ppt/notesSlides/notesSlide5.xml><?xml version="1.0" encoding="utf-8"?>
+<p:notes xmlns:p="http://schemas.openxmlformats.org/presentationml/2006/main">
+  <p:cSld>
+    <p:spTree>
+      <p:nvGrpSpPr>
+        <p:cNvPr id="1" name=""/>
+        <p:cNvGrpSpPr/>
+        <p:nvPr/>
+      </p:nvGrpSpPr>
+      <p:grpSpPr>
+        <a:xfrm xmlns:a="http://schemas.openxmlformats.org/drawingml/2006/main"/>
+      </p:grpSpPr>
+      <p:sp>
+        <p:nvSpPr>
+          <p:cNvPr id="2" name="Slide Image Placeholder 1"/>
+          <p:cNvSpPr>
+            <a:spLocks xmlns:a="http://schemas.openxmlformats.org/drawingml/2006/main" noGrp="1"/>
+          </p:cNvSpPr>
+          <p:nvPr>
+            <p:ph type="sldImg" idx="0"/>
+          </p:nvPr>
+        </p:nvSpPr>
+        <p:spPr/>
+      </p:sp>
+      <p:sp>
+        <p:nvSpPr>
+          <p:cNvPr id="3" name="Notes Placeholder 2"/>
+          <p:cNvSpPr>
+            <a:spLocks xmlns:a="http://schemas.openxmlformats.org/drawingml/2006/main" noGrp="1"/>
+          </p:cNvSpPr>
+          <p:nvPr>
+            <p:ph type="body" idx="1"/>
+          </p:nvPr>
+        </p:nvSpPr>
+        <p:spPr/>
+        <p:txBody>
+          <a:bodyPr xmlns:a="http://schemas.openxmlformats.org/drawingml/2006/main"/>
+          <a:lstStyle xmlns:a="http://schemas.openxmlformats.org/drawingml/2006/main"/>
+          <a:p xmlns:a="http://schemas.openxmlformats.org/drawingml/2006/main">
+            <a:r>
+              <a:t>This conclusion deliberately separates observation from mechanism.</a:t>
             </a:r>
           </a:p>
         </p:txBody>
@@ -510,7 +794,7 @@
   </p:cSld>
   <p:clrMap bg1="lt1" tx1="dk1" bg2="lt2" tx2="dk2" accent1="accent1" accent2="accent2" accent3="accent3" accent4="accent4" accent5="accent5" accent6="accent6" hlink="hlink" folHlink="folHlink"/>
   <p:sldLayoutIdLst>
-    <p:sldLayoutId xmlns:r="http://schemas.openxmlformats.org/officeDocument/2006/relationships" id="2147483649" r:id="R0a4a311301b34426"/>
+    <p:sldLayoutId xmlns:r="http://schemas.openxmlformats.org/officeDocument/2006/relationships" id="2147483649" r:id="Rd43ae92e70364fb5"/>
   </p:sldLayoutIdLst>
   <p:txStyles>
     <p:titleStyle>
@@ -1037,13 +1321,216 @@
 </a:theme>
 </file>
 
+<file path=ppt/slides/charts/chart1.xml><?xml version="1.0" encoding="utf-8"?>
+<c:chartSpace xmlns:c="http://schemas.openxmlformats.org/drawingml/2006/chart" xmlns:r="http://schemas.openxmlformats.org/officeDocument/2006/relationships">
+  <c:lang val="en-US"/>
+  <c:chart>
+    <c:plotArea>
+      <c:lineChart>
+        <c:grouping val="standard"/>
+        <c:ser>
+          <c:idx val="0"/>
+          <c:order val="0"/>
+          <c:tx>
+            <c:v>归一化峰宽</c:v>
+          </c:tx>
+          <c:spPr>
+            <a:ln xmlns:a="http://schemas.openxmlformats.org/drawingml/2006/main" w="28575">
+              <a:solidFill>
+                <a:srgbClr val="276B59"/>
+              </a:solidFill>
+            </a:ln>
+          </c:spPr>
+          <c:marker>
+            <c:symbol val="none"/>
+          </c:marker>
+          <c:cat>
+            <c:numRef>
+              <c:f>'Chart Data'!$A$2:$A$10</c:f>
+              <c:numCache>
+                <c:formatCode>General</c:formatCode>
+                <c:ptCount val="9"/>
+                <c:pt idx="0">
+                  <c:v>100</c:v>
+                </c:pt>
+                <c:pt idx="1">
+                  <c:v>125</c:v>
+                </c:pt>
+                <c:pt idx="2">
+                  <c:v>150</c:v>
+                </c:pt>
+                <c:pt idx="3">
+                  <c:v>175</c:v>
+                </c:pt>
+                <c:pt idx="4">
+                  <c:v>200</c:v>
+                </c:pt>
+                <c:pt idx="5">
+                  <c:v>225</c:v>
+                </c:pt>
+                <c:pt idx="6">
+                  <c:v>250</c:v>
+                </c:pt>
+                <c:pt idx="7">
+                  <c:v>275</c:v>
+                </c:pt>
+                <c:pt idx="8">
+                  <c:v>300</c:v>
+                </c:pt>
+              </c:numCache>
+            </c:numRef>
+          </c:cat>
+          <c:val>
+            <c:numRef>
+              <c:f>'Chart Data'!$B$2:$B$10</c:f>
+              <c:numCache>
+                <c:formatCode>General</c:formatCode>
+                <c:ptCount val="9"/>
+                <c:pt idx="0">
+                  <c:v>1</c:v>
+                </c:pt>
+                <c:pt idx="1">
+                  <c:v>0.96</c:v>
+                </c:pt>
+                <c:pt idx="2">
+                  <c:v>0.91</c:v>
+                </c:pt>
+                <c:pt idx="3">
+                  <c:v>0.86</c:v>
+                </c:pt>
+                <c:pt idx="4">
+                  <c:v>0.8</c:v>
+                </c:pt>
+                <c:pt idx="5">
+                  <c:v>0.75</c:v>
+                </c:pt>
+                <c:pt idx="6">
+                  <c:v>0.7</c:v>
+                </c:pt>
+                <c:pt idx="7">
+                  <c:v>0.66</c:v>
+                </c:pt>
+                <c:pt idx="8">
+                  <c:v>0.62</c:v>
+                </c:pt>
+              </c:numCache>
+            </c:numRef>
+          </c:val>
+        </c:ser>
+        <c:dLbls>
+          <c:txPr>
+            <a:bodyPr xmlns:a="http://schemas.openxmlformats.org/drawingml/2006/main" anchorCtr="1"/>
+            <a:lstStyle xmlns:a="http://schemas.openxmlformats.org/drawingml/2006/main"/>
+            <a:p xmlns:a="http://schemas.openxmlformats.org/drawingml/2006/main">
+              <a:pPr>
+                <a:defRPr>
+                  <a:latin typeface="Arial"/>
+                  <a:ea typeface="Arial"/>
+                  <a:cs typeface="Arial"/>
+                </a:defRPr>
+              </a:pPr>
+            </a:p>
+          </c:txPr>
+          <c:showLegendKey val="0"/>
+          <c:showVal val="1"/>
+          <c:showCatName val="0"/>
+          <c:showSerName val="0"/>
+          <c:showPercent val="0"/>
+          <c:showBubbleSize val="0"/>
+          <c:showLeaderLines val="0"/>
+        </c:dLbls>
+        <c:axId val="48650112"/>
+        <c:axId val="48672768"/>
+      </c:lineChart>
+      <c:catAx>
+        <c:axId val="48650112"/>
+        <c:scaling>
+          <c:orientation val="minMax"/>
+        </c:scaling>
+        <c:delete val="0"/>
+        <c:axPos val="b"/>
+        <c:numFmt formatCode="General"/>
+        <c:majorTickMark val="none"/>
+        <c:minorTickMark val="none"/>
+        <c:spPr>
+          <a:ln xmlns:a="http://schemas.openxmlformats.org/drawingml/2006/main" w="9525">
+            <a:solidFill>
+              <a:srgbClr val="D4D4D4"/>
+            </a:solidFill>
+            <a:prstDash val="solid"/>
+          </a:ln>
+        </c:spPr>
+        <c:txPr>
+          <a:bodyPr xmlns:a="http://schemas.openxmlformats.org/drawingml/2006/main" anchorCtr="1"/>
+          <a:lstStyle xmlns:a="http://schemas.openxmlformats.org/drawingml/2006/main"/>
+          <a:p xmlns:a="http://schemas.openxmlformats.org/drawingml/2006/main">
+            <a:pPr>
+              <a:defRPr>
+                <a:solidFill>
+                  <a:srgbClr val="666666"/>
+                </a:solidFill>
+                <a:latin typeface="Arial"/>
+                <a:ea typeface="Arial"/>
+                <a:cs typeface="Arial"/>
+              </a:defRPr>
+            </a:pPr>
+          </a:p>
+        </c:txPr>
+        <c:crossAx val="48672768"/>
+      </c:catAx>
+      <c:valAx>
+        <c:axId val="48672768"/>
+        <c:scaling>
+          <c:orientation val="minMax"/>
+        </c:scaling>
+        <c:delete val="1"/>
+        <c:axPos val="l"/>
+        <c:numFmt formatCode="General"/>
+        <c:majorTickMark val="none"/>
+        <c:minorTickMark val="none"/>
+        <c:spPr>
+          <a:ln xmlns:a="http://schemas.openxmlformats.org/drawingml/2006/main" w="9525">
+            <a:solidFill>
+              <a:srgbClr val="D4D4D4"/>
+            </a:solidFill>
+            <a:prstDash val="solid"/>
+          </a:ln>
+        </c:spPr>
+        <c:txPr>
+          <a:bodyPr xmlns:a="http://schemas.openxmlformats.org/drawingml/2006/main" anchorCtr="1"/>
+          <a:lstStyle xmlns:a="http://schemas.openxmlformats.org/drawingml/2006/main"/>
+          <a:p xmlns:a="http://schemas.openxmlformats.org/drawingml/2006/main">
+            <a:pPr>
+              <a:defRPr>
+                <a:solidFill>
+                  <a:srgbClr val="666666"/>
+                </a:solidFill>
+                <a:latin typeface="Arial"/>
+                <a:ea typeface="Arial"/>
+                <a:cs typeface="Arial"/>
+              </a:defRPr>
+            </a:pPr>
+          </a:p>
+        </c:txPr>
+        <c:crossAx val="48650112"/>
+        <c:crossBetween val="between"/>
+      </c:valAx>
+    </c:plotArea>
+    <c:plotVisOnly val="1"/>
+  </c:chart>
+  <c:externalData r:id="rIdChartSnapshot1">
+    <c:autoUpdate val="0"/>
+  </c:externalData>
+</c:chartSpace>
+</file>
+
 <file path=ppt/slides/slide1.xml><?xml version="1.0" encoding="utf-8"?>
 <p:sld xmlns:p="http://schemas.openxmlformats.org/presentationml/2006/main">
   <p:cSld>
     <p:bg>
       <p:bgPr>
         <a:solidFill xmlns:a="http://schemas.openxmlformats.org/drawingml/2006/main">
-          <a:srgbClr val="F7F8F6"/>
+          <a:srgbClr val="F3F6F3"/>
         </a:solidFill>
       </p:bgPr>
     </p:bg>
@@ -1058,10 +1545,10 @@
       </p:grpSpPr>
       <p:sp>
         <p:nvSpPr>
-          <p:cNvPr id="3" name="">
+          <p:cNvPr id="4" name="">
             <a:extLst xmlns:a="http://schemas.openxmlformats.org/drawingml/2006/main">
               <a:ext uri="{FF2B5EF4-FFF2-40B4-BE49-F238E27FC236}">
-                <a16:creationId xmlns:a16="http://schemas.microsoft.com/office/drawing/2014/main" id="{18DAFEAD-A378-460C-8406-C55FA871F62B}"/>
+                <a16:creationId xmlns:a16="http://schemas.microsoft.com/office/drawing/2014/main" id="{B2896801-DEFB-4E65-B20F-E0B9F4CB1C52}"/>
               </a:ext>
             </a:extLst>
           </p:cNvPr>
@@ -1072,8 +1559,8 @@
         </p:nvSpPr>
         <p:spPr>
           <a:xfrm xmlns:a="http://schemas.openxmlformats.org/drawingml/2006/main">
-            <a:off x="762000" y="590550"/>
-            <a:ext cx="10668000" cy="685800"/>
+            <a:off x="876300" y="1524000"/>
+            <a:ext cx="10382250" cy="857250"/>
           </a:xfrm>
           <a:prstGeom xmlns:a="http://schemas.openxmlformats.org/drawingml/2006/main" prst="rect">
             <a:avLst/>
@@ -1090,7 +1577,7 @@
           <a:lstStyle xmlns:a="http://schemas.openxmlformats.org/drawingml/2006/main"/>
           <a:p xmlns:a="http://schemas.openxmlformats.org/drawingml/2006/main">
             <a:pPr>
-              <a:defRPr sz="3150" b="1">
+              <a:defRPr sz="3450" b="1">
                 <a:solidFill>
                   <a:srgbClr val="18322A"/>
                 </a:solidFill>
@@ -1100,7 +1587,7 @@
               </a:defRPr>
             </a:pPr>
             <a:r>
-              <a:rPr sz="3150" b="1">
+              <a:rPr sz="3450" b="1">
                 <a:solidFill>
                   <a:srgbClr val="18322A"/>
                 </a:solidFill>
@@ -1108,7 +1595,7 @@
                 <a:ea typeface="Arial"/>
                 <a:cs typeface="Arial"/>
               </a:rPr>
-              <a:t>温度扫描实验示例</a:t>
+              <a:t>温度扫描与归一化峰宽</a:t>
             </a:r>
           </a:p>
         </p:txBody>
@@ -1118,7 +1605,7 @@
           <p:cNvPr id="2" name="">
             <a:extLst xmlns:a="http://schemas.openxmlformats.org/drawingml/2006/main">
               <a:ext uri="{FF2B5EF4-FFF2-40B4-BE49-F238E27FC236}">
-                <a16:creationId xmlns:a16="http://schemas.microsoft.com/office/drawing/2014/main" id="{FDA4C2F9-396B-45D8-B975-A146005318A9}"/>
+                <a16:creationId xmlns:a16="http://schemas.microsoft.com/office/drawing/2014/main" id="{2B8C6EC8-1D72-4518-B66A-CC28F0184F5A}"/>
               </a:ext>
             </a:extLst>
           </p:cNvPr>
@@ -1129,8 +1616,8 @@
         </p:nvSpPr>
         <p:spPr>
           <a:xfrm xmlns:a="http://schemas.openxmlformats.org/drawingml/2006/main">
-            <a:off x="800100" y="1809750"/>
-            <a:ext cx="10287000" cy="3048000"/>
+            <a:off x="914400" y="2571750"/>
+            <a:ext cx="9525000" cy="495300"/>
           </a:xfrm>
           <a:prstGeom xmlns:a="http://schemas.openxmlformats.org/drawingml/2006/main" prst="rect">
             <a:avLst/>
@@ -1147,9 +1634,9 @@
           <a:lstStyle xmlns:a="http://schemas.openxmlformats.org/drawingml/2006/main"/>
           <a:p xmlns:a="http://schemas.openxmlformats.org/drawingml/2006/main">
             <a:pPr>
-              <a:defRPr sz="1875">
-                <a:solidFill>
-                  <a:srgbClr val="253B34"/>
+              <a:defRPr sz="1725" b="0">
+                <a:solidFill>
+                  <a:srgbClr val="276B59"/>
                 </a:solidFill>
                 <a:latin typeface="Arial"/>
                 <a:ea typeface="Arial"/>
@@ -1157,22 +1644,336 @@
               </a:defRPr>
             </a:pPr>
             <a:r>
-              <a:rPr sz="1875">
-                <a:solidFill>
-                  <a:srgbClr val="253B34"/>
+              <a:rPr sz="1725" b="0">
+                <a:solidFill>
+                  <a:srgbClr val="276B59"/>
                 </a:solidFill>
                 <a:latin typeface="Arial"/>
                 <a:ea typeface="Arial"/>
                 <a:cs typeface="Arial"/>
               </a:rPr>
-              <a:t>实验目标</a:t>
+              <a:t>公开合成案例 | Research Slides 完整流程测试</a:t>
+            </a:r>
+          </a:p>
+        </p:txBody>
+      </p:sp>
+      <p:sp>
+        <p:nvSpPr>
+          <p:cNvPr id="3" name="">
+            <a:extLst xmlns:a="http://schemas.openxmlformats.org/drawingml/2006/main">
+              <a:ext uri="{FF2B5EF4-FFF2-40B4-BE49-F238E27FC236}">
+                <a16:creationId xmlns:a16="http://schemas.microsoft.com/office/drawing/2014/main" id="{FED89B43-1F09-4949-88A7-30B28E2338F4}"/>
+              </a:ext>
+            </a:extLst>
+          </p:cNvPr>
+          <p:cNvSpPr>
+            <a:spLocks xmlns:a="http://schemas.openxmlformats.org/drawingml/2006/main" noGrp="1"/>
+          </p:cNvSpPr>
+          <p:nvPr/>
+        </p:nvSpPr>
+        <p:spPr>
+          <a:xfrm xmlns:a="http://schemas.openxmlformats.org/drawingml/2006/main">
+            <a:off x="914400" y="4572000"/>
+            <a:ext cx="8572500" cy="428625"/>
+          </a:xfrm>
+          <a:prstGeom xmlns:a="http://schemas.openxmlformats.org/drawingml/2006/main" prst="rect">
+            <a:avLst/>
+          </a:prstGeom>
+          <a:noFill xmlns:a="http://schemas.openxmlformats.org/drawingml/2006/main"/>
+          <a:ln xmlns:a="http://schemas.openxmlformats.org/drawingml/2006/main" w="0">
+            <a:noFill/>
+          </a:ln>
+        </p:spPr>
+        <p:txBody>
+          <a:bodyPr xmlns:a="http://schemas.openxmlformats.org/drawingml/2006/main">
+            <a:noAutofit/>
+          </a:bodyPr>
+          <a:lstStyle xmlns:a="http://schemas.openxmlformats.org/drawingml/2006/main"/>
+          <a:p xmlns:a="http://schemas.openxmlformats.org/drawingml/2006/main">
+            <a:pPr>
+              <a:defRPr sz="1500" b="0">
+                <a:solidFill>
+                  <a:srgbClr val="65756E"/>
+                </a:solidFill>
+                <a:latin typeface="Arial"/>
+                <a:ea typeface="Arial"/>
+                <a:cs typeface="Arial"/>
+              </a:defRPr>
+            </a:pPr>
+            <a:r>
+              <a:rPr sz="1500" b="0">
+                <a:solidFill>
+                  <a:srgbClr val="65756E"/>
+                </a:solidFill>
+                <a:latin typeface="Arial"/>
+                <a:ea typeface="Arial"/>
+                <a:cs typeface="Arial"/>
+              </a:rPr>
+              <a:t>100-300 K · 9 个温度点 · 每点 10 s 积分</a:t>
+            </a:r>
+          </a:p>
+        </p:txBody>
+      </p:sp>
+    </p:spTree>
+    <p:extLst>
+      <p:ext uri="{BB962C8B-B14F-4D97-AF65-F5344CB8AC3E}">
+        <p14:creationId xmlns:p14="http://schemas.microsoft.com/office/powerpoint/2010/main" val="2133758766"/>
+      </p:ext>
+    </p:extLst>
+  </p:cSld>
+</p:sld>
+</file>
+
+<file path=ppt/slides/slide2.xml><?xml version="1.0" encoding="utf-8"?>
+<p:sld xmlns:p="http://schemas.openxmlformats.org/presentationml/2006/main">
+  <p:cSld>
+    <p:bg>
+      <p:bgPr>
+        <a:solidFill xmlns:a="http://schemas.openxmlformats.org/drawingml/2006/main">
+          <a:srgbClr val="FBFCFA"/>
+        </a:solidFill>
+      </p:bgPr>
+    </p:bg>
+    <p:spTree>
+      <p:nvGrpSpPr>
+        <p:cNvPr id="1" name=""/>
+        <p:cNvGrpSpPr/>
+        <p:nvPr/>
+      </p:nvGrpSpPr>
+      <p:grpSpPr>
+        <a:xfrm xmlns:a="http://schemas.openxmlformats.org/drawingml/2006/main"/>
+      </p:grpSpPr>
+      <p:sp>
+        <p:nvSpPr>
+          <p:cNvPr id="6" name="">
+            <a:extLst xmlns:a="http://schemas.openxmlformats.org/drawingml/2006/main">
+              <a:ext uri="{FF2B5EF4-FFF2-40B4-BE49-F238E27FC236}">
+                <a16:creationId xmlns:a16="http://schemas.microsoft.com/office/drawing/2014/main" id="{089EDAFE-0B57-4B7F-BCF8-7170CC7E8FE0}"/>
+              </a:ext>
+            </a:extLst>
+          </p:cNvPr>
+          <p:cNvSpPr>
+            <a:spLocks xmlns:a="http://schemas.openxmlformats.org/drawingml/2006/main" noGrp="1"/>
+          </p:cNvSpPr>
+          <p:nvPr/>
+        </p:nvSpPr>
+        <p:spPr>
+          <a:xfrm xmlns:a="http://schemas.openxmlformats.org/drawingml/2006/main">
+            <a:off x="704850" y="457200"/>
+            <a:ext cx="10763250" cy="590550"/>
+          </a:xfrm>
+          <a:prstGeom xmlns:a="http://schemas.openxmlformats.org/drawingml/2006/main" prst="rect">
+            <a:avLst/>
+          </a:prstGeom>
+          <a:noFill xmlns:a="http://schemas.openxmlformats.org/drawingml/2006/main"/>
+          <a:ln xmlns:a="http://schemas.openxmlformats.org/drawingml/2006/main" w="0">
+            <a:noFill/>
+          </a:ln>
+        </p:spPr>
+        <p:txBody>
+          <a:bodyPr xmlns:a="http://schemas.openxmlformats.org/drawingml/2006/main">
+            <a:noAutofit/>
+          </a:bodyPr>
+          <a:lstStyle xmlns:a="http://schemas.openxmlformats.org/drawingml/2006/main"/>
+          <a:p xmlns:a="http://schemas.openxmlformats.org/drawingml/2006/main">
+            <a:pPr>
+              <a:defRPr sz="2550" b="1">
+                <a:solidFill>
+                  <a:srgbClr val="18322A"/>
+                </a:solidFill>
+                <a:latin typeface="Arial"/>
+                <a:ea typeface="Arial"/>
+                <a:cs typeface="Arial"/>
+              </a:defRPr>
+            </a:pPr>
+            <a:r>
+              <a:rPr sz="2550" b="1">
+                <a:solidFill>
+                  <a:srgbClr val="18322A"/>
+                </a:solidFill>
+                <a:latin typeface="Arial"/>
+                <a:ea typeface="Arial"/>
+                <a:cs typeface="Arial"/>
+              </a:rPr>
+              <a:t>问题与测量定义</a:t>
+            </a:r>
+          </a:p>
+        </p:txBody>
+      </p:sp>
+      <p:sp>
+        <p:nvSpPr>
+          <p:cNvPr id="2" name="">
+            <a:extLst xmlns:a="http://schemas.openxmlformats.org/drawingml/2006/main">
+              <a:ext uri="{FF2B5EF4-FFF2-40B4-BE49-F238E27FC236}">
+                <a16:creationId xmlns:a16="http://schemas.microsoft.com/office/drawing/2014/main" id="{E2624CFE-61B4-475B-9381-DF0BCE5C53DB}"/>
+              </a:ext>
+            </a:extLst>
+          </p:cNvPr>
+          <p:cNvSpPr>
+            <a:spLocks xmlns:a="http://schemas.openxmlformats.org/drawingml/2006/main" noGrp="1"/>
+          </p:cNvSpPr>
+          <p:nvPr/>
+        </p:nvSpPr>
+        <p:spPr>
+          <a:xfrm xmlns:a="http://schemas.openxmlformats.org/drawingml/2006/main">
+            <a:off x="781050" y="1476375"/>
+            <a:ext cx="2857500" cy="457200"/>
+          </a:xfrm>
+          <a:prstGeom xmlns:a="http://schemas.openxmlformats.org/drawingml/2006/main" prst="rect">
+            <a:avLst/>
+          </a:prstGeom>
+          <a:noFill xmlns:a="http://schemas.openxmlformats.org/drawingml/2006/main"/>
+          <a:ln xmlns:a="http://schemas.openxmlformats.org/drawingml/2006/main" w="0">
+            <a:noFill/>
+          </a:ln>
+        </p:spPr>
+        <p:txBody>
+          <a:bodyPr xmlns:a="http://schemas.openxmlformats.org/drawingml/2006/main">
+            <a:noAutofit/>
+          </a:bodyPr>
+          <a:lstStyle xmlns:a="http://schemas.openxmlformats.org/drawingml/2006/main"/>
+          <a:p xmlns:a="http://schemas.openxmlformats.org/drawingml/2006/main">
+            <a:pPr>
+              <a:defRPr sz="1650" b="1">
+                <a:solidFill>
+                  <a:srgbClr val="276B59"/>
+                </a:solidFill>
+                <a:latin typeface="Arial"/>
+                <a:ea typeface="Arial"/>
+                <a:cs typeface="Arial"/>
+              </a:defRPr>
+            </a:pPr>
+            <a:r>
+              <a:rPr sz="1650" b="1">
+                <a:solidFill>
+                  <a:srgbClr val="276B59"/>
+                </a:solidFill>
+                <a:latin typeface="Arial"/>
+                <a:ea typeface="Arial"/>
+                <a:cs typeface="Arial"/>
+              </a:rPr>
+              <a:t>研究问题</a:t>
+            </a:r>
+          </a:p>
+        </p:txBody>
+      </p:sp>
+      <p:sp>
+        <p:nvSpPr>
+          <p:cNvPr id="3" name="">
+            <a:extLst xmlns:a="http://schemas.openxmlformats.org/drawingml/2006/main">
+              <a:ext uri="{FF2B5EF4-FFF2-40B4-BE49-F238E27FC236}">
+                <a16:creationId xmlns:a16="http://schemas.microsoft.com/office/drawing/2014/main" id="{4D522C01-3F11-4A3F-9A29-A76CFD16DD90}"/>
+              </a:ext>
+            </a:extLst>
+          </p:cNvPr>
+          <p:cNvSpPr>
+            <a:spLocks xmlns:a="http://schemas.openxmlformats.org/drawingml/2006/main" noGrp="1"/>
+          </p:cNvSpPr>
+          <p:nvPr/>
+        </p:nvSpPr>
+        <p:spPr>
+          <a:xfrm xmlns:a="http://schemas.openxmlformats.org/drawingml/2006/main">
+            <a:off x="781050" y="1952625"/>
+            <a:ext cx="10096500" cy="685800"/>
+          </a:xfrm>
+          <a:prstGeom xmlns:a="http://schemas.openxmlformats.org/drawingml/2006/main" prst="rect">
+            <a:avLst/>
+          </a:prstGeom>
+          <a:noFill xmlns:a="http://schemas.openxmlformats.org/drawingml/2006/main"/>
+          <a:ln xmlns:a="http://schemas.openxmlformats.org/drawingml/2006/main" w="0">
+            <a:noFill/>
+          </a:ln>
+        </p:spPr>
+        <p:txBody>
+          <a:bodyPr xmlns:a="http://schemas.openxmlformats.org/drawingml/2006/main">
+            <a:noAutofit/>
+          </a:bodyPr>
+          <a:lstStyle xmlns:a="http://schemas.openxmlformats.org/drawingml/2006/main"/>
+          <a:p xmlns:a="http://schemas.openxmlformats.org/drawingml/2006/main">
+            <a:pPr>
+              <a:defRPr sz="2250" b="1">
+                <a:solidFill>
+                  <a:srgbClr val="31443E"/>
+                </a:solidFill>
+                <a:latin typeface="Arial"/>
+                <a:ea typeface="Arial"/>
+                <a:cs typeface="Arial"/>
+              </a:defRPr>
+            </a:pPr>
+            <a:r>
+              <a:rPr sz="2250" b="1">
+                <a:solidFill>
+                  <a:srgbClr val="31443E"/>
+                </a:solidFill>
+                <a:latin typeface="Arial"/>
+                <a:ea typeface="Arial"/>
+                <a:cs typeface="Arial"/>
+              </a:rPr>
+              <a:t>升温过程中，归一化峰宽是否呈稳定的单调变化？</a:t>
+            </a:r>
+          </a:p>
+        </p:txBody>
+      </p:sp>
+      <p:sp>
+        <p:nvSpPr>
+          <p:cNvPr id="4" name="">
+            <a:extLst xmlns:a="http://schemas.openxmlformats.org/drawingml/2006/main">
+              <a:ext uri="{FF2B5EF4-FFF2-40B4-BE49-F238E27FC236}">
+                <a16:creationId xmlns:a16="http://schemas.microsoft.com/office/drawing/2014/main" id="{C82C09C0-C2E7-47FA-B455-B70AE6A2D2CA}"/>
+              </a:ext>
+            </a:extLst>
+          </p:cNvPr>
+          <p:cNvSpPr>
+            <a:spLocks xmlns:a="http://schemas.openxmlformats.org/drawingml/2006/main" noGrp="1"/>
+          </p:cNvSpPr>
+          <p:nvPr/>
+        </p:nvSpPr>
+        <p:spPr>
+          <a:xfrm xmlns:a="http://schemas.openxmlformats.org/drawingml/2006/main">
+            <a:off x="781050" y="3381375"/>
+            <a:ext cx="4762500" cy="1619250"/>
+          </a:xfrm>
+          <a:prstGeom xmlns:a="http://schemas.openxmlformats.org/drawingml/2006/main" prst="rect">
+            <a:avLst/>
+          </a:prstGeom>
+          <a:noFill xmlns:a="http://schemas.openxmlformats.org/drawingml/2006/main"/>
+          <a:ln xmlns:a="http://schemas.openxmlformats.org/drawingml/2006/main" w="0">
+            <a:noFill/>
+          </a:ln>
+        </p:spPr>
+        <p:txBody>
+          <a:bodyPr xmlns:a="http://schemas.openxmlformats.org/drawingml/2006/main">
+            <a:noAutofit/>
+          </a:bodyPr>
+          <a:lstStyle xmlns:a="http://schemas.openxmlformats.org/drawingml/2006/main"/>
+          <a:p xmlns:a="http://schemas.openxmlformats.org/drawingml/2006/main">
+            <a:pPr>
+              <a:defRPr sz="1575" b="0">
+                <a:solidFill>
+                  <a:srgbClr val="31443E"/>
+                </a:solidFill>
+                <a:latin typeface="Arial"/>
+                <a:ea typeface="Arial"/>
+                <a:cs typeface="Arial"/>
+              </a:defRPr>
+            </a:pPr>
+            <a:r>
+              <a:rPr sz="1575" b="0">
+                <a:solidFill>
+                  <a:srgbClr val="31443E"/>
+                </a:solidFill>
+                <a:latin typeface="Arial"/>
+                <a:ea typeface="Arial"/>
+                <a:cs typeface="Arial"/>
+              </a:rPr>
+              <a:t>定义</a:t>
             </a:r>
           </a:p>
           <a:p xmlns:a="http://schemas.openxmlformats.org/drawingml/2006/main">
             <a:pPr>
-              <a:defRPr sz="1875">
-                <a:solidFill>
-                  <a:srgbClr val="253B34"/>
+              <a:defRPr sz="1575" b="0">
+                <a:solidFill>
+                  <a:srgbClr val="31443E"/>
                 </a:solidFill>
                 <a:latin typeface="Arial"/>
                 <a:ea typeface="Arial"/>
@@ -1180,15 +1981,939 @@
               </a:defRPr>
             </a:pPr>
             <a:r>
-              <a:rPr sz="1875">
-                <a:solidFill>
-                  <a:srgbClr val="253B34"/>
+              <a:rPr sz="1575" b="0">
+                <a:solidFill>
+                  <a:srgbClr val="31443E"/>
                 </a:solidFill>
                 <a:latin typeface="Arial"/>
                 <a:ea typeface="Arial"/>
                 <a:cs typeface="Arial"/>
               </a:rPr>
-              <a:t>观察温度变化与归一化信号之间的关系</a:t>
+              <a:t>峰宽以 100 K 的拟合结果归一化。每个温度点采用相同的 10 s 积分时间，并报告合成标准差。</a:t>
+            </a:r>
+          </a:p>
+        </p:txBody>
+      </p:sp>
+      <p:sp>
+        <p:nvSpPr>
+          <p:cNvPr id="5" name="">
+            <a:extLst xmlns:a="http://schemas.openxmlformats.org/drawingml/2006/main">
+              <a:ext uri="{FF2B5EF4-FFF2-40B4-BE49-F238E27FC236}">
+                <a16:creationId xmlns:a16="http://schemas.microsoft.com/office/drawing/2014/main" id="{B496D53D-9A9D-4163-BA6B-899283B7854E}"/>
+              </a:ext>
+            </a:extLst>
+          </p:cNvPr>
+          <p:cNvSpPr>
+            <a:spLocks xmlns:a="http://schemas.openxmlformats.org/drawingml/2006/main" noGrp="1"/>
+          </p:cNvSpPr>
+          <p:nvPr/>
+        </p:nvSpPr>
+        <p:spPr>
+          <a:xfrm xmlns:a="http://schemas.openxmlformats.org/drawingml/2006/main">
+            <a:off x="6334125" y="3381375"/>
+            <a:ext cx="4762500" cy="1619250"/>
+          </a:xfrm>
+          <a:prstGeom xmlns:a="http://schemas.openxmlformats.org/drawingml/2006/main" prst="rect">
+            <a:avLst/>
+          </a:prstGeom>
+          <a:noFill xmlns:a="http://schemas.openxmlformats.org/drawingml/2006/main"/>
+          <a:ln xmlns:a="http://schemas.openxmlformats.org/drawingml/2006/main" w="0">
+            <a:noFill/>
+          </a:ln>
+        </p:spPr>
+        <p:txBody>
+          <a:bodyPr xmlns:a="http://schemas.openxmlformats.org/drawingml/2006/main">
+            <a:noAutofit/>
+          </a:bodyPr>
+          <a:lstStyle xmlns:a="http://schemas.openxmlformats.org/drawingml/2006/main"/>
+          <a:p xmlns:a="http://schemas.openxmlformats.org/drawingml/2006/main">
+            <a:pPr>
+              <a:defRPr sz="1575" b="0">
+                <a:solidFill>
+                  <a:srgbClr val="31443E"/>
+                </a:solidFill>
+                <a:latin typeface="Arial"/>
+                <a:ea typeface="Arial"/>
+                <a:cs typeface="Arial"/>
+              </a:defRPr>
+            </a:pPr>
+            <a:r>
+              <a:rPr sz="1575" b="0">
+                <a:solidFill>
+                  <a:srgbClr val="31443E"/>
+                </a:solidFill>
+                <a:latin typeface="Arial"/>
+                <a:ea typeface="Arial"/>
+                <a:cs typeface="Arial"/>
+              </a:rPr>
+              <a:t>解释边界</a:t>
+            </a:r>
+          </a:p>
+          <a:p xmlns:a="http://schemas.openxmlformats.org/drawingml/2006/main">
+            <a:pPr>
+              <a:defRPr sz="1575" b="0">
+                <a:solidFill>
+                  <a:srgbClr val="31443E"/>
+                </a:solidFill>
+                <a:latin typeface="Arial"/>
+                <a:ea typeface="Arial"/>
+                <a:cs typeface="Arial"/>
+              </a:defRPr>
+            </a:pPr>
+            <a:r>
+              <a:rPr sz="1575" b="0">
+                <a:solidFill>
+                  <a:srgbClr val="31443E"/>
+                </a:solidFill>
+                <a:latin typeface="Arial"/>
+                <a:ea typeface="Arial"/>
+                <a:cs typeface="Arial"/>
+              </a:rPr>
+              <a:t>单调趋势是观察结果。散射、展宽机制或仪器漂移仍需额外测量区分。</a:t>
+            </a:r>
+          </a:p>
+        </p:txBody>
+      </p:sp>
+    </p:spTree>
+    <p:extLst>
+      <p:ext uri="{BB962C8B-B14F-4D97-AF65-F5344CB8AC3E}">
+        <p14:creationId xmlns:p14="http://schemas.microsoft.com/office/powerpoint/2010/main" val="1534755143"/>
+      </p:ext>
+    </p:extLst>
+  </p:cSld>
+</p:sld>
+</file>
+
+<file path=ppt/slides/slide3.xml><?xml version="1.0" encoding="utf-8"?>
+<p:sld xmlns:p="http://schemas.openxmlformats.org/presentationml/2006/main">
+  <p:cSld>
+    <p:bg>
+      <p:bgPr>
+        <a:solidFill xmlns:a="http://schemas.openxmlformats.org/drawingml/2006/main">
+          <a:srgbClr val="FBFCFA"/>
+        </a:solidFill>
+      </p:bgPr>
+    </p:bg>
+    <p:spTree>
+      <p:nvGrpSpPr>
+        <p:cNvPr id="1" name=""/>
+        <p:cNvGrpSpPr/>
+        <p:nvPr/>
+      </p:nvGrpSpPr>
+      <p:grpSpPr>
+        <a:xfrm xmlns:a="http://schemas.openxmlformats.org/drawingml/2006/main"/>
+      </p:grpSpPr>
+      <p:sp>
+        <p:nvSpPr>
+          <p:cNvPr id="4" name="">
+            <a:extLst xmlns:a="http://schemas.openxmlformats.org/drawingml/2006/main">
+              <a:ext uri="{FF2B5EF4-FFF2-40B4-BE49-F238E27FC236}">
+                <a16:creationId xmlns:a16="http://schemas.microsoft.com/office/drawing/2014/main" id="{DCDBDE05-06E0-4F6C-A0C8-6258A2EA5726}"/>
+              </a:ext>
+            </a:extLst>
+          </p:cNvPr>
+          <p:cNvSpPr>
+            <a:spLocks xmlns:a="http://schemas.openxmlformats.org/drawingml/2006/main" noGrp="1"/>
+          </p:cNvSpPr>
+          <p:nvPr/>
+        </p:nvSpPr>
+        <p:spPr>
+          <a:xfrm xmlns:a="http://schemas.openxmlformats.org/drawingml/2006/main">
+            <a:off x="704850" y="457200"/>
+            <a:ext cx="10763250" cy="590550"/>
+          </a:xfrm>
+          <a:prstGeom xmlns:a="http://schemas.openxmlformats.org/drawingml/2006/main" prst="rect">
+            <a:avLst/>
+          </a:prstGeom>
+          <a:noFill xmlns:a="http://schemas.openxmlformats.org/drawingml/2006/main"/>
+          <a:ln xmlns:a="http://schemas.openxmlformats.org/drawingml/2006/main" w="0">
+            <a:noFill/>
+          </a:ln>
+        </p:spPr>
+        <p:txBody>
+          <a:bodyPr xmlns:a="http://schemas.openxmlformats.org/drawingml/2006/main">
+            <a:noAutofit/>
+          </a:bodyPr>
+          <a:lstStyle xmlns:a="http://schemas.openxmlformats.org/drawingml/2006/main"/>
+          <a:p xmlns:a="http://schemas.openxmlformats.org/drawingml/2006/main">
+            <a:pPr>
+              <a:defRPr sz="2550" b="1">
+                <a:solidFill>
+                  <a:srgbClr val="18322A"/>
+                </a:solidFill>
+                <a:latin typeface="Arial"/>
+                <a:ea typeface="Arial"/>
+                <a:cs typeface="Arial"/>
+              </a:defRPr>
+            </a:pPr>
+            <a:r>
+              <a:rPr sz="2550" b="1">
+                <a:solidFill>
+                  <a:srgbClr val="18322A"/>
+                </a:solidFill>
+                <a:latin typeface="Arial"/>
+                <a:ea typeface="Arial"/>
+                <a:cs typeface="Arial"/>
+              </a:rPr>
+              <a:t>峰宽随温度单调下降</a:t>
+            </a:r>
+          </a:p>
+        </p:txBody>
+      </p:sp>
+      <p:graphicFrame>
+        <p:nvGraphicFramePr>
+          <p:cNvPr id="5" name="Chart"/>
+          <p:cNvGraphicFramePr/>
+          <p:nvPr/>
+        </p:nvGraphicFramePr>
+        <p:xfrm>
+          <a:off xmlns:a="http://schemas.openxmlformats.org/drawingml/2006/main" x="876300" y="1381125"/>
+          <a:ext xmlns:a="http://schemas.openxmlformats.org/drawingml/2006/main" cx="10287000" cy="4095750"/>
+        </p:xfrm>
+        <a:graphic xmlns:a="http://schemas.openxmlformats.org/drawingml/2006/main">
+          <a:graphicData uri="http://schemas.openxmlformats.org/drawingml/2006/chart">
+            <c:chart xmlns:r="http://schemas.openxmlformats.org/officeDocument/2006/relationships" xmlns:c="http://schemas.openxmlformats.org/drawingml/2006/chart" r:id="Rd62427cbb8be4dea"/>
+          </a:graphicData>
+        </a:graphic>
+      </p:graphicFrame>
+      <p:sp>
+        <p:nvSpPr>
+          <p:cNvPr id="3" name="">
+            <a:extLst xmlns:a="http://schemas.openxmlformats.org/drawingml/2006/main">
+              <a:ext uri="{FF2B5EF4-FFF2-40B4-BE49-F238E27FC236}">
+                <a16:creationId xmlns:a16="http://schemas.microsoft.com/office/drawing/2014/main" id="{3237881D-7BFD-4458-89C7-1C3641D7CBEB}"/>
+              </a:ext>
+            </a:extLst>
+          </p:cNvPr>
+          <p:cNvSpPr>
+            <a:spLocks xmlns:a="http://schemas.openxmlformats.org/drawingml/2006/main" noGrp="1"/>
+          </p:cNvSpPr>
+          <p:nvPr/>
+        </p:nvSpPr>
+        <p:spPr>
+          <a:xfrm xmlns:a="http://schemas.openxmlformats.org/drawingml/2006/main">
+            <a:off x="5286375" y="5619750"/>
+            <a:ext cx="1714500" cy="333375"/>
+          </a:xfrm>
+          <a:prstGeom xmlns:a="http://schemas.openxmlformats.org/drawingml/2006/main" prst="rect">
+            <a:avLst/>
+          </a:prstGeom>
+          <a:noFill xmlns:a="http://schemas.openxmlformats.org/drawingml/2006/main"/>
+          <a:ln xmlns:a="http://schemas.openxmlformats.org/drawingml/2006/main" w="0">
+            <a:noFill/>
+          </a:ln>
+        </p:spPr>
+        <p:txBody>
+          <a:bodyPr xmlns:a="http://schemas.openxmlformats.org/drawingml/2006/main">
+            <a:noAutofit/>
+          </a:bodyPr>
+          <a:lstStyle xmlns:a="http://schemas.openxmlformats.org/drawingml/2006/main"/>
+          <a:p xmlns:a="http://schemas.openxmlformats.org/drawingml/2006/main">
+            <a:pPr>
+              <a:defRPr sz="1350" b="0">
+                <a:solidFill>
+                  <a:srgbClr val="65756E"/>
+                </a:solidFill>
+                <a:latin typeface="Arial"/>
+                <a:ea typeface="Arial"/>
+                <a:cs typeface="Arial"/>
+              </a:defRPr>
+            </a:pPr>
+            <a:r>
+              <a:rPr sz="1350" b="0">
+                <a:solidFill>
+                  <a:srgbClr val="65756E"/>
+                </a:solidFill>
+                <a:latin typeface="Arial"/>
+                <a:ea typeface="Arial"/>
+                <a:cs typeface="Arial"/>
+              </a:rPr>
+              <a:t>温度 (K)</a:t>
+            </a:r>
+          </a:p>
+        </p:txBody>
+      </p:sp>
+    </p:spTree>
+    <p:extLst>
+      <p:ext uri="{BB962C8B-B14F-4D97-AF65-F5344CB8AC3E}">
+        <p14:creationId xmlns:p14="http://schemas.microsoft.com/office/powerpoint/2010/main" val="1531363325"/>
+      </p:ext>
+    </p:extLst>
+  </p:cSld>
+</p:sld>
+</file>
+
+<file path=ppt/slides/slide4.xml><?xml version="1.0" encoding="utf-8"?>
+<p:sld xmlns:p="http://schemas.openxmlformats.org/presentationml/2006/main">
+  <p:cSld>
+    <p:bg>
+      <p:bgPr>
+        <a:solidFill xmlns:a="http://schemas.openxmlformats.org/drawingml/2006/main">
+          <a:srgbClr val="FBFCFA"/>
+        </a:solidFill>
+      </p:bgPr>
+    </p:bg>
+    <p:spTree>
+      <p:nvGrpSpPr>
+        <p:cNvPr id="1" name=""/>
+        <p:cNvGrpSpPr/>
+        <p:nvPr/>
+      </p:nvGrpSpPr>
+      <p:grpSpPr>
+        <a:xfrm xmlns:a="http://schemas.openxmlformats.org/drawingml/2006/main"/>
+      </p:grpSpPr>
+      <p:sp>
+        <p:nvSpPr>
+          <p:cNvPr id="7" name="">
+            <a:extLst xmlns:a="http://schemas.openxmlformats.org/drawingml/2006/main">
+              <a:ext uri="{FF2B5EF4-FFF2-40B4-BE49-F238E27FC236}">
+                <a16:creationId xmlns:a16="http://schemas.microsoft.com/office/drawing/2014/main" id="{B927B367-1196-4F28-A53A-602161CAE629}"/>
+              </a:ext>
+            </a:extLst>
+          </p:cNvPr>
+          <p:cNvSpPr>
+            <a:spLocks xmlns:a="http://schemas.openxmlformats.org/drawingml/2006/main" noGrp="1"/>
+          </p:cNvSpPr>
+          <p:nvPr/>
+        </p:nvSpPr>
+        <p:spPr>
+          <a:xfrm xmlns:a="http://schemas.openxmlformats.org/drawingml/2006/main">
+            <a:off x="704850" y="457200"/>
+            <a:ext cx="10763250" cy="590550"/>
+          </a:xfrm>
+          <a:prstGeom xmlns:a="http://schemas.openxmlformats.org/drawingml/2006/main" prst="rect">
+            <a:avLst/>
+          </a:prstGeom>
+          <a:noFill xmlns:a="http://schemas.openxmlformats.org/drawingml/2006/main"/>
+          <a:ln xmlns:a="http://schemas.openxmlformats.org/drawingml/2006/main" w="0">
+            <a:noFill/>
+          </a:ln>
+        </p:spPr>
+        <p:txBody>
+          <a:bodyPr xmlns:a="http://schemas.openxmlformats.org/drawingml/2006/main">
+            <a:noAutofit/>
+          </a:bodyPr>
+          <a:lstStyle xmlns:a="http://schemas.openxmlformats.org/drawingml/2006/main"/>
+          <a:p xmlns:a="http://schemas.openxmlformats.org/drawingml/2006/main">
+            <a:pPr>
+              <a:defRPr sz="2550" b="1">
+                <a:solidFill>
+                  <a:srgbClr val="18322A"/>
+                </a:solidFill>
+                <a:latin typeface="Arial"/>
+                <a:ea typeface="Arial"/>
+                <a:cs typeface="Arial"/>
+              </a:defRPr>
+            </a:pPr>
+            <a:r>
+              <a:rPr sz="2550" b="1">
+                <a:solidFill>
+                  <a:srgbClr val="18322A"/>
+                </a:solidFill>
+                <a:latin typeface="Arial"/>
+                <a:ea typeface="Arial"/>
+                <a:cs typeface="Arial"/>
+              </a:rPr>
+              <a:t>变化幅度与不确定性</a:t>
+            </a:r>
+          </a:p>
+        </p:txBody>
+      </p:sp>
+      <p:sp>
+        <p:nvSpPr>
+          <p:cNvPr id="2" name="">
+            <a:extLst xmlns:a="http://schemas.openxmlformats.org/drawingml/2006/main">
+              <a:ext uri="{FF2B5EF4-FFF2-40B4-BE49-F238E27FC236}">
+                <a16:creationId xmlns:a16="http://schemas.microsoft.com/office/drawing/2014/main" id="{CDC20D12-FF68-496D-BCF7-AEC44E67CCD9}"/>
+              </a:ext>
+            </a:extLst>
+          </p:cNvPr>
+          <p:cNvSpPr>
+            <a:spLocks xmlns:a="http://schemas.openxmlformats.org/drawingml/2006/main" noGrp="1"/>
+          </p:cNvSpPr>
+          <p:nvPr/>
+        </p:nvSpPr>
+        <p:spPr>
+          <a:xfrm xmlns:a="http://schemas.openxmlformats.org/drawingml/2006/main">
+            <a:off x="857250" y="1571625"/>
+            <a:ext cx="3333750" cy="1000125"/>
+          </a:xfrm>
+          <a:prstGeom xmlns:a="http://schemas.openxmlformats.org/drawingml/2006/main" prst="rect">
+            <a:avLst/>
+          </a:prstGeom>
+          <a:noFill xmlns:a="http://schemas.openxmlformats.org/drawingml/2006/main"/>
+          <a:ln xmlns:a="http://schemas.openxmlformats.org/drawingml/2006/main" w="0">
+            <a:noFill/>
+          </a:ln>
+        </p:spPr>
+        <p:txBody>
+          <a:bodyPr xmlns:a="http://schemas.openxmlformats.org/drawingml/2006/main">
+            <a:noAutofit/>
+          </a:bodyPr>
+          <a:lstStyle xmlns:a="http://schemas.openxmlformats.org/drawingml/2006/main"/>
+          <a:p xmlns:a="http://schemas.openxmlformats.org/drawingml/2006/main">
+            <a:pPr>
+              <a:defRPr sz="5100" b="1">
+                <a:solidFill>
+                  <a:srgbClr val="276B59"/>
+                </a:solidFill>
+                <a:latin typeface="Arial"/>
+                <a:ea typeface="Arial"/>
+                <a:cs typeface="Arial"/>
+              </a:defRPr>
+            </a:pPr>
+            <a:r>
+              <a:rPr sz="5100" b="1">
+                <a:solidFill>
+                  <a:srgbClr val="276B59"/>
+                </a:solidFill>
+                <a:latin typeface="Arial"/>
+                <a:ea typeface="Arial"/>
+                <a:cs typeface="Arial"/>
+              </a:rPr>
+              <a:t>38%</a:t>
+            </a:r>
+          </a:p>
+        </p:txBody>
+      </p:sp>
+      <p:sp>
+        <p:nvSpPr>
+          <p:cNvPr id="3" name="">
+            <a:extLst xmlns:a="http://schemas.openxmlformats.org/drawingml/2006/main">
+              <a:ext uri="{FF2B5EF4-FFF2-40B4-BE49-F238E27FC236}">
+                <a16:creationId xmlns:a16="http://schemas.microsoft.com/office/drawing/2014/main" id="{80FF36B7-9628-4DC0-A30E-EB96BE52A5C0}"/>
+              </a:ext>
+            </a:extLst>
+          </p:cNvPr>
+          <p:cNvSpPr>
+            <a:spLocks xmlns:a="http://schemas.openxmlformats.org/drawingml/2006/main" noGrp="1"/>
+          </p:cNvSpPr>
+          <p:nvPr/>
+        </p:nvSpPr>
+        <p:spPr>
+          <a:xfrm xmlns:a="http://schemas.openxmlformats.org/drawingml/2006/main">
+            <a:off x="904875" y="2628900"/>
+            <a:ext cx="4095750" cy="476250"/>
+          </a:xfrm>
+          <a:prstGeom xmlns:a="http://schemas.openxmlformats.org/drawingml/2006/main" prst="rect">
+            <a:avLst/>
+          </a:prstGeom>
+          <a:noFill xmlns:a="http://schemas.openxmlformats.org/drawingml/2006/main"/>
+          <a:ln xmlns:a="http://schemas.openxmlformats.org/drawingml/2006/main" w="0">
+            <a:noFill/>
+          </a:ln>
+        </p:spPr>
+        <p:txBody>
+          <a:bodyPr xmlns:a="http://schemas.openxmlformats.org/drawingml/2006/main">
+            <a:noAutofit/>
+          </a:bodyPr>
+          <a:lstStyle xmlns:a="http://schemas.openxmlformats.org/drawingml/2006/main"/>
+          <a:p xmlns:a="http://schemas.openxmlformats.org/drawingml/2006/main">
+            <a:pPr>
+              <a:defRPr sz="1650" b="0">
+                <a:solidFill>
+                  <a:srgbClr val="31443E"/>
+                </a:solidFill>
+                <a:latin typeface="Arial"/>
+                <a:ea typeface="Arial"/>
+                <a:cs typeface="Arial"/>
+              </a:defRPr>
+            </a:pPr>
+            <a:r>
+              <a:rPr sz="1650" b="0">
+                <a:solidFill>
+                  <a:srgbClr val="31443E"/>
+                </a:solidFill>
+                <a:latin typeface="Arial"/>
+                <a:ea typeface="Arial"/>
+                <a:cs typeface="Arial"/>
+              </a:rPr>
+              <a:t>100 K 到 300 K 的总降幅</a:t>
+            </a:r>
+          </a:p>
+        </p:txBody>
+      </p:sp>
+      <p:sp>
+        <p:nvSpPr>
+          <p:cNvPr id="4" name="">
+            <a:extLst xmlns:a="http://schemas.openxmlformats.org/drawingml/2006/main">
+              <a:ext uri="{FF2B5EF4-FFF2-40B4-BE49-F238E27FC236}">
+                <a16:creationId xmlns:a16="http://schemas.microsoft.com/office/drawing/2014/main" id="{592C328F-2C1F-4BD6-9EC3-370E0EAD0E0E}"/>
+              </a:ext>
+            </a:extLst>
+          </p:cNvPr>
+          <p:cNvSpPr>
+            <a:spLocks xmlns:a="http://schemas.openxmlformats.org/drawingml/2006/main" noGrp="1"/>
+          </p:cNvSpPr>
+          <p:nvPr/>
+        </p:nvSpPr>
+        <p:spPr>
+          <a:xfrm xmlns:a="http://schemas.openxmlformats.org/drawingml/2006/main">
+            <a:off x="6191250" y="1571625"/>
+            <a:ext cx="3810000" cy="457200"/>
+          </a:xfrm>
+          <a:prstGeom xmlns:a="http://schemas.openxmlformats.org/drawingml/2006/main" prst="rect">
+            <a:avLst/>
+          </a:prstGeom>
+          <a:noFill xmlns:a="http://schemas.openxmlformats.org/drawingml/2006/main"/>
+          <a:ln xmlns:a="http://schemas.openxmlformats.org/drawingml/2006/main" w="0">
+            <a:noFill/>
+          </a:ln>
+        </p:spPr>
+        <p:txBody>
+          <a:bodyPr xmlns:a="http://schemas.openxmlformats.org/drawingml/2006/main">
+            <a:noAutofit/>
+          </a:bodyPr>
+          <a:lstStyle xmlns:a="http://schemas.openxmlformats.org/drawingml/2006/main"/>
+          <a:p xmlns:a="http://schemas.openxmlformats.org/drawingml/2006/main">
+            <a:pPr>
+              <a:defRPr sz="1800" b="1">
+                <a:solidFill>
+                  <a:srgbClr val="18322A"/>
+                </a:solidFill>
+                <a:latin typeface="Arial"/>
+                <a:ea typeface="Arial"/>
+                <a:cs typeface="Arial"/>
+              </a:defRPr>
+            </a:pPr>
+            <a:r>
+              <a:rPr sz="1800" b="1">
+                <a:solidFill>
+                  <a:srgbClr val="18322A"/>
+                </a:solidFill>
+                <a:latin typeface="Arial"/>
+                <a:ea typeface="Arial"/>
+                <a:cs typeface="Arial"/>
+              </a:rPr>
+              <a:t>相邻区间降幅</a:t>
+            </a:r>
+          </a:p>
+        </p:txBody>
+      </p:sp>
+      <p:sp>
+        <p:nvSpPr>
+          <p:cNvPr id="5" name="">
+            <a:extLst xmlns:a="http://schemas.openxmlformats.org/drawingml/2006/main">
+              <a:ext uri="{FF2B5EF4-FFF2-40B4-BE49-F238E27FC236}">
+                <a16:creationId xmlns:a16="http://schemas.microsoft.com/office/drawing/2014/main" id="{1094EB3B-CE8A-4459-8950-A0D9A079D552}"/>
+              </a:ext>
+            </a:extLst>
+          </p:cNvPr>
+          <p:cNvSpPr>
+            <a:spLocks xmlns:a="http://schemas.openxmlformats.org/drawingml/2006/main" noGrp="1"/>
+          </p:cNvSpPr>
+          <p:nvPr/>
+        </p:nvSpPr>
+        <p:spPr>
+          <a:xfrm xmlns:a="http://schemas.openxmlformats.org/drawingml/2006/main">
+            <a:off x="6191250" y="2143125"/>
+            <a:ext cx="4095750" cy="762000"/>
+          </a:xfrm>
+          <a:prstGeom xmlns:a="http://schemas.openxmlformats.org/drawingml/2006/main" prst="rect">
+            <a:avLst/>
+          </a:prstGeom>
+          <a:noFill xmlns:a="http://schemas.openxmlformats.org/drawingml/2006/main"/>
+          <a:ln xmlns:a="http://schemas.openxmlformats.org/drawingml/2006/main" w="0">
+            <a:noFill/>
+          </a:ln>
+        </p:spPr>
+        <p:txBody>
+          <a:bodyPr xmlns:a="http://schemas.openxmlformats.org/drawingml/2006/main">
+            <a:noAutofit/>
+          </a:bodyPr>
+          <a:lstStyle xmlns:a="http://schemas.openxmlformats.org/drawingml/2006/main"/>
+          <a:p xmlns:a="http://schemas.openxmlformats.org/drawingml/2006/main">
+            <a:pPr>
+              <a:defRPr sz="3600" b="1">
+                <a:solidFill>
+                  <a:srgbClr val="C56B32"/>
+                </a:solidFill>
+                <a:latin typeface="Arial"/>
+                <a:ea typeface="Arial"/>
+                <a:cs typeface="Arial"/>
+              </a:defRPr>
+            </a:pPr>
+            <a:r>
+              <a:rPr sz="3600" b="1">
+                <a:solidFill>
+                  <a:srgbClr val="C56B32"/>
+                </a:solidFill>
+                <a:latin typeface="Arial"/>
+                <a:ea typeface="Arial"/>
+                <a:cs typeface="Arial"/>
+              </a:rPr>
+              <a:t>3.9%-6.6%</a:t>
+            </a:r>
+          </a:p>
+        </p:txBody>
+      </p:sp>
+      <p:sp>
+        <p:nvSpPr>
+          <p:cNvPr id="6" name="">
+            <a:extLst xmlns:a="http://schemas.openxmlformats.org/drawingml/2006/main">
+              <a:ext uri="{FF2B5EF4-FFF2-40B4-BE49-F238E27FC236}">
+                <a16:creationId xmlns:a16="http://schemas.microsoft.com/office/drawing/2014/main" id="{C3D2B446-80EE-4A72-B184-8916CFDD4B5A}"/>
+              </a:ext>
+            </a:extLst>
+          </p:cNvPr>
+          <p:cNvSpPr>
+            <a:spLocks xmlns:a="http://schemas.openxmlformats.org/drawingml/2006/main" noGrp="1"/>
+          </p:cNvSpPr>
+          <p:nvPr/>
+        </p:nvSpPr>
+        <p:spPr>
+          <a:xfrm xmlns:a="http://schemas.openxmlformats.org/drawingml/2006/main">
+            <a:off x="904875" y="3952875"/>
+            <a:ext cx="10096500" cy="1190625"/>
+          </a:xfrm>
+          <a:prstGeom xmlns:a="http://schemas.openxmlformats.org/drawingml/2006/main" prst="rect">
+            <a:avLst/>
+          </a:prstGeom>
+          <a:noFill xmlns:a="http://schemas.openxmlformats.org/drawingml/2006/main"/>
+          <a:ln xmlns:a="http://schemas.openxmlformats.org/drawingml/2006/main" w="0">
+            <a:noFill/>
+          </a:ln>
+        </p:spPr>
+        <p:txBody>
+          <a:bodyPr xmlns:a="http://schemas.openxmlformats.org/drawingml/2006/main">
+            <a:noAutofit/>
+          </a:bodyPr>
+          <a:lstStyle xmlns:a="http://schemas.openxmlformats.org/drawingml/2006/main"/>
+          <a:p xmlns:a="http://schemas.openxmlformats.org/drawingml/2006/main">
+            <a:pPr>
+              <a:defRPr sz="1800" b="0">
+                <a:solidFill>
+                  <a:srgbClr val="31443E"/>
+                </a:solidFill>
+                <a:latin typeface="Arial"/>
+                <a:ea typeface="Arial"/>
+                <a:cs typeface="Arial"/>
+              </a:defRPr>
+            </a:pPr>
+            <a:r>
+              <a:rPr sz="1800" b="0">
+                <a:solidFill>
+                  <a:srgbClr val="31443E"/>
+                </a:solidFill>
+                <a:latin typeface="Arial"/>
+                <a:ea typeface="Arial"/>
+                <a:cs typeface="Arial"/>
+              </a:rPr>
+              <a:t>趋势连续，但当前数据不足以判定具体物理机制。估计标准差从 0.030 降至 0.019，误差模型仍需真实重复实验验证。</a:t>
+            </a:r>
+          </a:p>
+        </p:txBody>
+      </p:sp>
+    </p:spTree>
+    <p:extLst>
+      <p:ext uri="{BB962C8B-B14F-4D97-AF65-F5344CB8AC3E}">
+        <p14:creationId xmlns:p14="http://schemas.microsoft.com/office/powerpoint/2010/main" val="64639495"/>
+      </p:ext>
+    </p:extLst>
+  </p:cSld>
+</p:sld>
+</file>
+
+<file path=ppt/slides/slide5.xml><?xml version="1.0" encoding="utf-8"?>
+<p:sld xmlns:p="http://schemas.openxmlformats.org/presentationml/2006/main">
+  <p:cSld>
+    <p:bg>
+      <p:bgPr>
+        <a:solidFill xmlns:a="http://schemas.openxmlformats.org/drawingml/2006/main">
+          <a:srgbClr val="FBFCFA"/>
+        </a:solidFill>
+      </p:bgPr>
+    </p:bg>
+    <p:spTree>
+      <p:nvGrpSpPr>
+        <p:cNvPr id="1" name=""/>
+        <p:cNvGrpSpPr/>
+        <p:nvPr/>
+      </p:nvGrpSpPr>
+      <p:grpSpPr>
+        <a:xfrm xmlns:a="http://schemas.openxmlformats.org/drawingml/2006/main"/>
+      </p:grpSpPr>
+      <p:sp>
+        <p:nvSpPr>
+          <p:cNvPr id="7" name="">
+            <a:extLst xmlns:a="http://schemas.openxmlformats.org/drawingml/2006/main">
+              <a:ext uri="{FF2B5EF4-FFF2-40B4-BE49-F238E27FC236}">
+                <a16:creationId xmlns:a16="http://schemas.microsoft.com/office/drawing/2014/main" id="{AB4CED50-7C6E-4B36-A686-F6952B1C5854}"/>
+              </a:ext>
+            </a:extLst>
+          </p:cNvPr>
+          <p:cNvSpPr>
+            <a:spLocks xmlns:a="http://schemas.openxmlformats.org/drawingml/2006/main" noGrp="1"/>
+          </p:cNvSpPr>
+          <p:nvPr/>
+        </p:nvSpPr>
+        <p:spPr>
+          <a:xfrm xmlns:a="http://schemas.openxmlformats.org/drawingml/2006/main">
+            <a:off x="704850" y="457200"/>
+            <a:ext cx="10763250" cy="590550"/>
+          </a:xfrm>
+          <a:prstGeom xmlns:a="http://schemas.openxmlformats.org/drawingml/2006/main" prst="rect">
+            <a:avLst/>
+          </a:prstGeom>
+          <a:noFill xmlns:a="http://schemas.openxmlformats.org/drawingml/2006/main"/>
+          <a:ln xmlns:a="http://schemas.openxmlformats.org/drawingml/2006/main" w="0">
+            <a:noFill/>
+          </a:ln>
+        </p:spPr>
+        <p:txBody>
+          <a:bodyPr xmlns:a="http://schemas.openxmlformats.org/drawingml/2006/main">
+            <a:noAutofit/>
+          </a:bodyPr>
+          <a:lstStyle xmlns:a="http://schemas.openxmlformats.org/drawingml/2006/main"/>
+          <a:p xmlns:a="http://schemas.openxmlformats.org/drawingml/2006/main">
+            <a:pPr>
+              <a:defRPr sz="2550" b="1">
+                <a:solidFill>
+                  <a:srgbClr val="18322A"/>
+                </a:solidFill>
+                <a:latin typeface="Arial"/>
+                <a:ea typeface="Arial"/>
+                <a:cs typeface="Arial"/>
+              </a:defRPr>
+            </a:pPr>
+            <a:r>
+              <a:rPr sz="2550" b="1">
+                <a:solidFill>
+                  <a:srgbClr val="18322A"/>
+                </a:solidFill>
+                <a:latin typeface="Arial"/>
+                <a:ea typeface="Arial"/>
+                <a:cs typeface="Arial"/>
+              </a:rPr>
+              <a:t>局限与下一步测量</a:t>
+            </a:r>
+          </a:p>
+        </p:txBody>
+      </p:sp>
+      <p:sp>
+        <p:nvSpPr>
+          <p:cNvPr id="2" name="">
+            <a:extLst xmlns:a="http://schemas.openxmlformats.org/drawingml/2006/main">
+              <a:ext uri="{FF2B5EF4-FFF2-40B4-BE49-F238E27FC236}">
+                <a16:creationId xmlns:a16="http://schemas.microsoft.com/office/drawing/2014/main" id="{0172BE49-2277-42D8-A47A-DE9FD593D05E}"/>
+              </a:ext>
+            </a:extLst>
+          </p:cNvPr>
+          <p:cNvSpPr>
+            <a:spLocks xmlns:a="http://schemas.openxmlformats.org/drawingml/2006/main" noGrp="1"/>
+          </p:cNvSpPr>
+          <p:nvPr/>
+        </p:nvSpPr>
+        <p:spPr>
+          <a:xfrm xmlns:a="http://schemas.openxmlformats.org/drawingml/2006/main">
+            <a:off x="809625" y="1476375"/>
+            <a:ext cx="4191000" cy="457200"/>
+          </a:xfrm>
+          <a:prstGeom xmlns:a="http://schemas.openxmlformats.org/drawingml/2006/main" prst="rect">
+            <a:avLst/>
+          </a:prstGeom>
+          <a:noFill xmlns:a="http://schemas.openxmlformats.org/drawingml/2006/main"/>
+          <a:ln xmlns:a="http://schemas.openxmlformats.org/drawingml/2006/main" w="0">
+            <a:noFill/>
+          </a:ln>
+        </p:spPr>
+        <p:txBody>
+          <a:bodyPr xmlns:a="http://schemas.openxmlformats.org/drawingml/2006/main">
+            <a:noAutofit/>
+          </a:bodyPr>
+          <a:lstStyle xmlns:a="http://schemas.openxmlformats.org/drawingml/2006/main"/>
+          <a:p xmlns:a="http://schemas.openxmlformats.org/drawingml/2006/main">
+            <a:pPr>
+              <a:defRPr sz="1800" b="1">
+                <a:solidFill>
+                  <a:srgbClr val="C56B32"/>
+                </a:solidFill>
+                <a:latin typeface="Arial"/>
+                <a:ea typeface="Arial"/>
+                <a:cs typeface="Arial"/>
+              </a:defRPr>
+            </a:pPr>
+            <a:r>
+              <a:rPr sz="1800" b="1">
+                <a:solidFill>
+                  <a:srgbClr val="C56B32"/>
+                </a:solidFill>
+                <a:latin typeface="Arial"/>
+                <a:ea typeface="Arial"/>
+                <a:cs typeface="Arial"/>
+              </a:rPr>
+              <a:t>当前局限</a:t>
+            </a:r>
+          </a:p>
+        </p:txBody>
+      </p:sp>
+      <p:sp>
+        <p:nvSpPr>
+          <p:cNvPr id="3" name="">
+            <a:extLst xmlns:a="http://schemas.openxmlformats.org/drawingml/2006/main">
+              <a:ext uri="{FF2B5EF4-FFF2-40B4-BE49-F238E27FC236}">
+                <a16:creationId xmlns:a16="http://schemas.microsoft.com/office/drawing/2014/main" id="{BDB97585-4BF6-4E03-A16E-5446AB28BA8E}"/>
+              </a:ext>
+            </a:extLst>
+          </p:cNvPr>
+          <p:cNvSpPr>
+            <a:spLocks xmlns:a="http://schemas.openxmlformats.org/drawingml/2006/main" noGrp="1"/>
+          </p:cNvSpPr>
+          <p:nvPr/>
+        </p:nvSpPr>
+        <p:spPr>
+          <a:xfrm xmlns:a="http://schemas.openxmlformats.org/drawingml/2006/main">
+            <a:off x="809625" y="2095500"/>
+            <a:ext cx="4572000" cy="1952625"/>
+          </a:xfrm>
+          <a:prstGeom xmlns:a="http://schemas.openxmlformats.org/drawingml/2006/main" prst="rect">
+            <a:avLst/>
+          </a:prstGeom>
+          <a:noFill xmlns:a="http://schemas.openxmlformats.org/drawingml/2006/main"/>
+          <a:ln xmlns:a="http://schemas.openxmlformats.org/drawingml/2006/main" w="0">
+            <a:noFill/>
+          </a:ln>
+        </p:spPr>
+        <p:txBody>
+          <a:bodyPr xmlns:a="http://schemas.openxmlformats.org/drawingml/2006/main">
+            <a:noAutofit/>
+          </a:bodyPr>
+          <a:lstStyle xmlns:a="http://schemas.openxmlformats.org/drawingml/2006/main"/>
+          <a:p xmlns:a="http://schemas.openxmlformats.org/drawingml/2006/main">
+            <a:pPr>
+              <a:defRPr sz="1725" b="0">
+                <a:solidFill>
+                  <a:srgbClr val="31443E"/>
+                </a:solidFill>
+                <a:latin typeface="Arial"/>
+                <a:ea typeface="Arial"/>
+                <a:cs typeface="Arial"/>
+              </a:defRPr>
+            </a:pPr>
+            <a:r>
+              <a:rPr sz="1725" b="0">
+                <a:solidFill>
+                  <a:srgbClr val="31443E"/>
+                </a:solidFill>
+                <a:latin typeface="Arial"/>
+                <a:ea typeface="Arial"/>
+                <a:cs typeface="Arial"/>
+              </a:rPr>
+              <a:t>单次合成扫描无法排除温度滞后、拟合模型偏差和仪器漂移。归一化还会传播 100 K 参考点的不确定性。</a:t>
+            </a:r>
+          </a:p>
+        </p:txBody>
+      </p:sp>
+      <p:sp>
+        <p:nvSpPr>
+          <p:cNvPr id="4" name="">
+            <a:extLst xmlns:a="http://schemas.openxmlformats.org/drawingml/2006/main">
+              <a:ext uri="{FF2B5EF4-FFF2-40B4-BE49-F238E27FC236}">
+                <a16:creationId xmlns:a16="http://schemas.microsoft.com/office/drawing/2014/main" id="{A6499FDB-F77D-44EA-AAB4-055ED86B0DF3}"/>
+              </a:ext>
+            </a:extLst>
+          </p:cNvPr>
+          <p:cNvSpPr>
+            <a:spLocks xmlns:a="http://schemas.openxmlformats.org/drawingml/2006/main" noGrp="1"/>
+          </p:cNvSpPr>
+          <p:nvPr/>
+        </p:nvSpPr>
+        <p:spPr>
+          <a:xfrm xmlns:a="http://schemas.openxmlformats.org/drawingml/2006/main">
+            <a:off x="6524625" y="1476375"/>
+            <a:ext cx="4191000" cy="457200"/>
+          </a:xfrm>
+          <a:prstGeom xmlns:a="http://schemas.openxmlformats.org/drawingml/2006/main" prst="rect">
+            <a:avLst/>
+          </a:prstGeom>
+          <a:noFill xmlns:a="http://schemas.openxmlformats.org/drawingml/2006/main"/>
+          <a:ln xmlns:a="http://schemas.openxmlformats.org/drawingml/2006/main" w="0">
+            <a:noFill/>
+          </a:ln>
+        </p:spPr>
+        <p:txBody>
+          <a:bodyPr xmlns:a="http://schemas.openxmlformats.org/drawingml/2006/main">
+            <a:noAutofit/>
+          </a:bodyPr>
+          <a:lstStyle xmlns:a="http://schemas.openxmlformats.org/drawingml/2006/main"/>
+          <a:p xmlns:a="http://schemas.openxmlformats.org/drawingml/2006/main">
+            <a:pPr>
+              <a:defRPr sz="1800" b="1">
+                <a:solidFill>
+                  <a:srgbClr val="276B59"/>
+                </a:solidFill>
+                <a:latin typeface="Arial"/>
+                <a:ea typeface="Arial"/>
+                <a:cs typeface="Arial"/>
+              </a:defRPr>
+            </a:pPr>
+            <a:r>
+              <a:rPr sz="1800" b="1">
+                <a:solidFill>
+                  <a:srgbClr val="276B59"/>
+                </a:solidFill>
+                <a:latin typeface="Arial"/>
+                <a:ea typeface="Arial"/>
+                <a:cs typeface="Arial"/>
+              </a:rPr>
+              <a:t>建议验证</a:t>
+            </a:r>
+          </a:p>
+        </p:txBody>
+      </p:sp>
+      <p:sp>
+        <p:nvSpPr>
+          <p:cNvPr id="5" name="">
+            <a:extLst xmlns:a="http://schemas.openxmlformats.org/drawingml/2006/main">
+              <a:ext uri="{FF2B5EF4-FFF2-40B4-BE49-F238E27FC236}">
+                <a16:creationId xmlns:a16="http://schemas.microsoft.com/office/drawing/2014/main" id="{F6694F94-6907-49FF-87D4-C0DDF2D76AA7}"/>
+              </a:ext>
+            </a:extLst>
+          </p:cNvPr>
+          <p:cNvSpPr>
+            <a:spLocks xmlns:a="http://schemas.openxmlformats.org/drawingml/2006/main" noGrp="1"/>
+          </p:cNvSpPr>
+          <p:nvPr/>
+        </p:nvSpPr>
+        <p:spPr>
+          <a:xfrm xmlns:a="http://schemas.openxmlformats.org/drawingml/2006/main">
+            <a:off x="6524625" y="2095500"/>
+            <a:ext cx="4572000" cy="1952625"/>
+          </a:xfrm>
+          <a:prstGeom xmlns:a="http://schemas.openxmlformats.org/drawingml/2006/main" prst="rect">
+            <a:avLst/>
+          </a:prstGeom>
+          <a:noFill xmlns:a="http://schemas.openxmlformats.org/drawingml/2006/main"/>
+          <a:ln xmlns:a="http://schemas.openxmlformats.org/drawingml/2006/main" w="0">
+            <a:noFill/>
+          </a:ln>
+        </p:spPr>
+        <p:txBody>
+          <a:bodyPr xmlns:a="http://schemas.openxmlformats.org/drawingml/2006/main">
+            <a:noAutofit/>
+          </a:bodyPr>
+          <a:lstStyle xmlns:a="http://schemas.openxmlformats.org/drawingml/2006/main"/>
+          <a:p xmlns:a="http://schemas.openxmlformats.org/drawingml/2006/main">
+            <a:pPr>
+              <a:defRPr sz="1725" b="0">
+                <a:solidFill>
+                  <a:srgbClr val="31443E"/>
+                </a:solidFill>
+                <a:latin typeface="Arial"/>
+                <a:ea typeface="Arial"/>
+                <a:cs typeface="Arial"/>
+              </a:defRPr>
+            </a:pPr>
+            <a:r>
+              <a:rPr sz="1725" b="0">
+                <a:solidFill>
+                  <a:srgbClr val="31443E"/>
+                </a:solidFill>
+                <a:latin typeface="Arial"/>
+                <a:ea typeface="Arial"/>
+                <a:cs typeface="Arial"/>
+              </a:rPr>
+              <a:t>执行升温与降温双向扫描，检验滞后。</a:t>
             </a:r>
           </a:p>
           <a:p xmlns:a="http://schemas.openxmlformats.org/drawingml/2006/main">
@@ -1198,9 +2923,9 @@
           </a:p>
           <a:p xmlns:a="http://schemas.openxmlformats.org/drawingml/2006/main">
             <a:pPr>
-              <a:defRPr sz="1875">
-                <a:solidFill>
-                  <a:srgbClr val="253B34"/>
+              <a:defRPr sz="1725" b="0">
+                <a:solidFill>
+                  <a:srgbClr val="31443E"/>
                 </a:solidFill>
                 <a:latin typeface="Arial"/>
                 <a:ea typeface="Arial"/>
@@ -1208,22 +2933,56 @@
               </a:defRPr>
             </a:pPr>
             <a:r>
-              <a:rPr sz="1875">
-                <a:solidFill>
-                  <a:srgbClr val="253B34"/>
+              <a:rPr sz="1725" b="0">
+                <a:solidFill>
+                  <a:srgbClr val="31443E"/>
                 </a:solidFill>
                 <a:latin typeface="Arial"/>
                 <a:ea typeface="Arial"/>
                 <a:cs typeface="Arial"/>
               </a:rPr>
-              <a:t>示例数据</a:t>
+              <a:t>加入稳定参考样品，区分样品变化与仪器漂移。</a:t>
             </a:r>
           </a:p>
+        </p:txBody>
+      </p:sp>
+      <p:sp>
+        <p:nvSpPr>
+          <p:cNvPr id="6" name="">
+            <a:extLst xmlns:a="http://schemas.openxmlformats.org/drawingml/2006/main">
+              <a:ext uri="{FF2B5EF4-FFF2-40B4-BE49-F238E27FC236}">
+                <a16:creationId xmlns:a16="http://schemas.microsoft.com/office/drawing/2014/main" id="{B9361B4A-C0DE-4738-8586-AADAF05F197B}"/>
+              </a:ext>
+            </a:extLst>
+          </p:cNvPr>
+          <p:cNvSpPr>
+            <a:spLocks xmlns:a="http://schemas.openxmlformats.org/drawingml/2006/main" noGrp="1"/>
+          </p:cNvSpPr>
+          <p:nvPr/>
+        </p:nvSpPr>
+        <p:spPr>
+          <a:xfrm xmlns:a="http://schemas.openxmlformats.org/drawingml/2006/main">
+            <a:off x="809625" y="5095875"/>
+            <a:ext cx="10287000" cy="666750"/>
+          </a:xfrm>
+          <a:prstGeom xmlns:a="http://schemas.openxmlformats.org/drawingml/2006/main" prst="rect">
+            <a:avLst/>
+          </a:prstGeom>
+          <a:noFill xmlns:a="http://schemas.openxmlformats.org/drawingml/2006/main"/>
+          <a:ln xmlns:a="http://schemas.openxmlformats.org/drawingml/2006/main" w="0">
+            <a:noFill/>
+          </a:ln>
+        </p:spPr>
+        <p:txBody>
+          <a:bodyPr xmlns:a="http://schemas.openxmlformats.org/drawingml/2006/main">
+            <a:noAutofit/>
+          </a:bodyPr>
+          <a:lstStyle xmlns:a="http://schemas.openxmlformats.org/drawingml/2006/main"/>
           <a:p xmlns:a="http://schemas.openxmlformats.org/drawingml/2006/main">
             <a:pPr>
-              <a:defRPr sz="1875">
-                <a:solidFill>
-                  <a:srgbClr val="253B34"/>
+              <a:defRPr sz="1875" b="1">
+                <a:solidFill>
+                  <a:srgbClr val="18322A"/>
                 </a:solidFill>
                 <a:latin typeface="Arial"/>
                 <a:ea typeface="Arial"/>
@@ -1231,66 +2990,15 @@
               </a:defRPr>
             </a:pPr>
             <a:r>
-              <a:rPr sz="1875">
-                <a:solidFill>
-                  <a:srgbClr val="253B34"/>
+              <a:rPr sz="1875" b="1">
+                <a:solidFill>
+                  <a:srgbClr val="18322A"/>
                 </a:solidFill>
                 <a:latin typeface="Arial"/>
                 <a:ea typeface="Arial"/>
                 <a:cs typeface="Arial"/>
               </a:rPr>
-              <a:t>20 °C：0.41    30 °C：0.57    40 °C：0.76    50 °C：0.88</a:t>
-            </a:r>
-          </a:p>
-          <a:p xmlns:a="http://schemas.openxmlformats.org/drawingml/2006/main">
-            <a:r>
-              <a:t/>
-            </a:r>
-          </a:p>
-          <a:p xmlns:a="http://schemas.openxmlformats.org/drawingml/2006/main">
-            <a:pPr>
-              <a:defRPr sz="1875">
-                <a:solidFill>
-                  <a:srgbClr val="253B34"/>
-                </a:solidFill>
-                <a:latin typeface="Arial"/>
-                <a:ea typeface="Arial"/>
-                <a:cs typeface="Arial"/>
-              </a:defRPr>
-            </a:pPr>
-            <a:r>
-              <a:rPr sz="1875">
-                <a:solidFill>
-                  <a:srgbClr val="253B34"/>
-                </a:solidFill>
-                <a:latin typeface="Arial"/>
-                <a:ea typeface="Arial"/>
-                <a:cs typeface="Arial"/>
-              </a:rPr>
-              <a:t>说明</a:t>
-            </a:r>
-          </a:p>
-          <a:p xmlns:a="http://schemas.openxmlformats.org/drawingml/2006/main">
-            <a:pPr>
-              <a:defRPr sz="1875">
-                <a:solidFill>
-                  <a:srgbClr val="253B34"/>
-                </a:solidFill>
-                <a:latin typeface="Arial"/>
-                <a:ea typeface="Arial"/>
-                <a:cs typeface="Arial"/>
-              </a:defRPr>
-            </a:pPr>
-            <a:r>
-              <a:rPr sz="1875">
-                <a:solidFill>
-                  <a:srgbClr val="253B34"/>
-                </a:solidFill>
-                <a:latin typeface="Arial"/>
-                <a:ea typeface="Arial"/>
-                <a:cs typeface="Arial"/>
-              </a:rPr>
-              <a:t>这是随软件发布的合成案例，不代表真实实验结论。</a:t>
+              <a:t>结论：合成数据支持“峰宽随温度下降”的描述，但不支持未经验证的机制归因。</a:t>
             </a:r>
           </a:p>
         </p:txBody>
@@ -1298,7 +3006,7 @@
     </p:spTree>
     <p:extLst>
       <p:ext uri="{BB962C8B-B14F-4D97-AF65-F5344CB8AC3E}">
-        <p14:creationId xmlns:p14="http://schemas.microsoft.com/office/powerpoint/2010/main" val="2057370331"/>
+        <p14:creationId xmlns:p14="http://schemas.microsoft.com/office/powerpoint/2010/main" val="1121187124"/>
       </p:ext>
     </p:extLst>
   </p:cSld>

</xml_diff>